<commit_message>
docs: update Gamma presentation with current timing terminology
</commit_message>
<xml_diff>
--- a/docs/gamma/AI-Supply-Chain-Risk-Intelligence-Platform-v2.pptx
+++ b/docs/gamma/AI-Supply-Chain-Risk-Intelligence-Platform-v2.pptx
@@ -8708,7 +8708,7 @@
                 <a:ea typeface="PT Sans" pitchFamily="34" charset="-122"/>
                 <a:cs typeface="PT Sans" pitchFamily="34" charset="-120"/>
               </a:rPr>
-              <a:t>24 hours only · stale news blocked</a:t>
+              <a:t>48 hours only · stale news blocked</a:t>
             </a:r>
             <a:endParaRPr lang="en-US" sz="600" dirty="0"/>
           </a:p>
@@ -9380,7 +9380,7 @@
                 <a:ea typeface="PT Sans Bold" pitchFamily="34" charset="-122"/>
                 <a:cs typeface="PT Sans Bold" pitchFamily="34" charset="-120"/>
               </a:rPr>
-              <a:t>DAILY SUMMARY</a:t>
+              <a:t>SCHEDULED SUMMARY</a:t>
             </a:r>
             <a:endParaRPr lang="en-US" sz="600" dirty="0"/>
           </a:p>
@@ -11327,7 +11327,7 @@
                 <a:ea typeface="PT Sans" pitchFamily="34" charset="-122"/>
                 <a:cs typeface="PT Sans" pitchFamily="34" charset="-120"/>
               </a:rPr>
-              <a:t>24-hour age filter applied; duplicate URLs suppressed before analysis</a:t>
+              <a:t>48-hour age filter applied; duplicate URLs suppressed before analysis</a:t>
             </a:r>
             <a:endParaRPr lang="en-US" sz="700" dirty="0"/>
           </a:p>
@@ -13561,7 +13561,7 @@
                 <a:ea typeface="PT Sans" pitchFamily="34" charset="-122"/>
                 <a:cs typeface="PT Sans" pitchFamily="34" charset="-120"/>
               </a:rPr>
-              <a:t>Only articles published within the last 24 hours are processed. Stale news cannot trigger alerts or inflate risk scores.</a:t>
+              <a:t>Only articles published within the last 48 hours are processed. Stale news cannot trigger alerts or inflate risk scores.</a:t>
             </a:r>
             <a:endParaRPr lang="en-US" sz="1000" dirty="0"/>
           </a:p>

</xml_diff>